<commit_message>
Fix issues found in independent review pass
- Rebalance quiz answer-key distribution in Ch7, 8, 9, 10, 12 guides (was mostly "b")
- Fix broken/circular cross-chapter references across Ch3, 6, 7, 8, 9, 11, 12, 15, 16, 17
- Remove residual UND/mascot references in Ch13 guide and deck
- Genericize a real accounting firm's name used in a Ch10 case study
- Correct a Carnegie misquote and mislabeled paraphrase in Ch16
- Fix minor citation misattributions (Wired author, attention-research term, MUM-effect years, Cialdini principle count)
- Rename Ch6's goodwill framework away from a textbook-specific label
- Fix a stem/answer mismatch and a syntax bug in the exam system
- Harden exam.html: obfuscate the answer key, fix a shared-computer session collision, fix a timezone bug in the instructor prefill
</commit_message>
<xml_diff>
--- a/slides/ch06-positive-and-neutral-messages.pptx
+++ b/slides/ch06-positive-and-neutral-messages.pptx
@@ -6101,7 +6101,7 @@
       <p:grpSpPr/>
       <p:sp>
         <p:nvSpPr>
-          <p:cNvPr id="2" name="Title 1" descr="Slide title: The five-S test"/>
+          <p:cNvPr id="2" name="Title 1" descr="Slide title: The five-quality test"/>
           <p:cNvSpPr>
             <a:spLocks noGrp="1"/>
           </p:cNvSpPr>
@@ -6127,7 +6127,7 @@
                 </a:solidFill>
                 <a:latin typeface="Cambria"/>
               </a:rPr>
-              <a:t>The five-S test</a:t>
+              <a:t>The five-quality test</a:t>
             </a:r>
           </a:p>
         </p:txBody>
@@ -7349,7 +7349,7 @@
                 </a:solidFill>
                 <a:latin typeface="Calibri"/>
               </a:rPr>
-              <a:t>send one five-S note this week. Actually send it.</a:t>
+              <a:t>send one five-quality note this week. Actually send it.</a:t>
             </a:r>
           </a:p>
         </p:txBody>
@@ -9775,7 +9775,7 @@
                 </a:solidFill>
                 <a:latin typeface="Calibri"/>
               </a:rPr>
-              <a:t>goodwill that passes the five-S test — the highest-return mail there is.</a:t>
+              <a:t>goodwill that passes the five-quality test — the highest-return mail there is.</a:t>
             </a:r>
           </a:p>
         </p:txBody>
@@ -12371,7 +12371,7 @@
                 </a:solidFill>
                 <a:latin typeface="Calibri"/>
               </a:rPr>
-              <a:t>The five-S note that reaches a personnel file outlives every hallway compliment.</a:t>
+              <a:t>The five-quality note that reaches a personnel file outlives every hallway compliment.</a:t>
             </a:r>
           </a:p>
         </p:txBody>
@@ -13246,7 +13246,7 @@
                 </a:solidFill>
                 <a:latin typeface="Calibri"/>
               </a:rPr>
-              <a:t>Goodwill passes five-S; ink for milestones; never AI — the pause is the message.</a:t>
+              <a:t>Goodwill passes five-quality; ink for milestones; never AI — the pause is the message.</a:t>
             </a:r>
           </a:p>
         </p:txBody>
@@ -14335,7 +14335,7 @@
                 </a:solidFill>
                 <a:latin typeface="Calibri"/>
               </a:rPr>
-              <a:t>One real five-S goodwill note this week. Note what comes back.</a:t>
+              <a:t>One real five-quality goodwill note this week. Note what comes back.</a:t>
             </a:r>
           </a:p>
           <a:p>

</xml_diff>